<commit_message>
Intègre les vraies photos clients dans le mur des créateurs
- Avatars ronds (recadrage cercle + anneau dégradé) à partir des
  photos fournies, avec repli automatique sur les initiales.
- Photos rangées dans assets/clients/ (chemin par défaut du build).

Co-Authored-By: Claude Opus 4.8 <noreply@anthropic.com>
Claude-Session: https://claude.ai/code/session_01SEzgxP8UjCbxgDgZR7qL7k
</commit_message>
<xml_diff>
--- a/Masterclass_Facebook_KevinChris_REDESIGN.pptx
+++ b/Masterclass_Facebook_KevinChris_REDESIGN.pptx
@@ -22759,8 +22759,8 @@
         </p:nvSpPr>
         <p:spPr>
           <a:xfrm>
-            <a:off x="1464256" y="2423160"/>
-            <a:ext cx="694944" cy="694944"/>
+            <a:off x="1418536" y="2377440"/>
+            <a:ext cx="786384" cy="786384"/>
           </a:xfrm>
           <a:prstGeom prst="ellipse">
             <a:avLst/>
@@ -22809,12 +22809,20 @@
           </a:p>
         </p:txBody>
       </p:sp>
-      <p:sp>
-        <p:nvSpPr>
-          <p:cNvPr id="12" name="TextBox 11"/>
-          <p:cNvSpPr txBox="1"/>
-          <p:nvPr/>
-        </p:nvSpPr>
+      <p:pic>
+        <p:nvPicPr>
+          <p:cNvPr id="12" name="Picture 11" descr="laurisse-digital.png"/>
+          <p:cNvPicPr>
+            <a:picLocks noChangeAspect="1"/>
+          </p:cNvPicPr>
+          <p:nvPr/>
+        </p:nvPicPr>
+        <p:blipFill>
+          <a:blip r:embed="rId2"/>
+          <a:stretch>
+            <a:fillRect/>
+          </a:stretch>
+        </p:blipFill>
         <p:spPr>
           <a:xfrm>
             <a:off x="1464256" y="2423160"/>
@@ -22823,27 +22831,8 @@
           <a:prstGeom prst="rect">
             <a:avLst/>
           </a:prstGeom>
-          <a:noFill/>
-        </p:spPr>
-        <p:txBody>
-          <a:bodyPr wrap="square" lIns="0" rIns="0" tIns="0" bIns="0" anchor="ctr">
-            <a:spAutoFit/>
-          </a:bodyPr>
-          <a:lstStyle/>
-          <a:p>
-            <a:pPr algn="ctr"/>
-            <a:r>
-              <a:rPr sz="2280" b="0">
-                <a:solidFill>
-                  <a:srgbClr val="FFFFFF"/>
-                </a:solidFill>
-                <a:latin typeface="Montserrat Black"/>
-              </a:rPr>
-              <a:t>LD</a:t>
-            </a:r>
-          </a:p>
-        </p:txBody>
-      </p:sp>
+        </p:spPr>
+      </p:pic>
       <p:sp>
         <p:nvSpPr>
           <p:cNvPr id="13" name="TextBox 12"/>
@@ -23070,8 +23059,8 @@
         </p:nvSpPr>
         <p:spPr>
           <a:xfrm>
-            <a:off x="3606384" y="2423160"/>
-            <a:ext cx="694944" cy="694944"/>
+            <a:off x="3560664" y="2377440"/>
+            <a:ext cx="786384" cy="786384"/>
           </a:xfrm>
           <a:prstGeom prst="ellipse">
             <a:avLst/>
@@ -23120,12 +23109,20 @@
           </a:p>
         </p:txBody>
       </p:sp>
-      <p:sp>
-        <p:nvSpPr>
-          <p:cNvPr id="19" name="TextBox 18"/>
-          <p:cNvSpPr txBox="1"/>
-          <p:nvPr/>
-        </p:nvSpPr>
+      <p:pic>
+        <p:nvPicPr>
+          <p:cNvPr id="19" name="Picture 18" descr="le-mb-bandjounais.png"/>
+          <p:cNvPicPr>
+            <a:picLocks noChangeAspect="1"/>
+          </p:cNvPicPr>
+          <p:nvPr/>
+        </p:nvPicPr>
+        <p:blipFill>
+          <a:blip r:embed="rId3"/>
+          <a:stretch>
+            <a:fillRect/>
+          </a:stretch>
+        </p:blipFill>
         <p:spPr>
           <a:xfrm>
             <a:off x="3606384" y="2423160"/>
@@ -23134,27 +23131,8 @@
           <a:prstGeom prst="rect">
             <a:avLst/>
           </a:prstGeom>
-          <a:noFill/>
-        </p:spPr>
-        <p:txBody>
-          <a:bodyPr wrap="square" lIns="0" rIns="0" tIns="0" bIns="0" anchor="ctr">
-            <a:spAutoFit/>
-          </a:bodyPr>
-          <a:lstStyle/>
-          <a:p>
-            <a:pPr algn="ctr"/>
-            <a:r>
-              <a:rPr sz="2280" b="0">
-                <a:solidFill>
-                  <a:srgbClr val="FFFFFF"/>
-                </a:solidFill>
-                <a:latin typeface="Montserrat Black"/>
-              </a:rPr>
-              <a:t>LM</a:t>
-            </a:r>
-          </a:p>
-        </p:txBody>
-      </p:sp>
+        </p:spPr>
+      </p:pic>
       <p:sp>
         <p:nvSpPr>
           <p:cNvPr id="20" name="TextBox 19"/>
@@ -23381,8 +23359,8 @@
         </p:nvSpPr>
         <p:spPr>
           <a:xfrm>
-            <a:off x="5748512" y="2423160"/>
-            <a:ext cx="694944" cy="694944"/>
+            <a:off x="5702792" y="2377440"/>
+            <a:ext cx="786384" cy="786384"/>
           </a:xfrm>
           <a:prstGeom prst="ellipse">
             <a:avLst/>
@@ -23431,12 +23409,20 @@
           </a:p>
         </p:txBody>
       </p:sp>
-      <p:sp>
-        <p:nvSpPr>
-          <p:cNvPr id="26" name="TextBox 25"/>
-          <p:cNvSpPr txBox="1"/>
-          <p:nvPr/>
-        </p:nvSpPr>
+      <p:pic>
+        <p:nvPicPr>
+          <p:cNvPr id="26" name="Picture 25" descr="letoile-kribienne.png"/>
+          <p:cNvPicPr>
+            <a:picLocks noChangeAspect="1"/>
+          </p:cNvPicPr>
+          <p:nvPr/>
+        </p:nvPicPr>
+        <p:blipFill>
+          <a:blip r:embed="rId4"/>
+          <a:stretch>
+            <a:fillRect/>
+          </a:stretch>
+        </p:blipFill>
         <p:spPr>
           <a:xfrm>
             <a:off x="5748512" y="2423160"/>
@@ -23445,27 +23431,8 @@
           <a:prstGeom prst="rect">
             <a:avLst/>
           </a:prstGeom>
-          <a:noFill/>
-        </p:spPr>
-        <p:txBody>
-          <a:bodyPr wrap="square" lIns="0" rIns="0" tIns="0" bIns="0" anchor="ctr">
-            <a:spAutoFit/>
-          </a:bodyPr>
-          <a:lstStyle/>
-          <a:p>
-            <a:pPr algn="ctr"/>
-            <a:r>
-              <a:rPr sz="2280" b="0">
-                <a:solidFill>
-                  <a:srgbClr val="FFFFFF"/>
-                </a:solidFill>
-                <a:latin typeface="Montserrat Black"/>
-              </a:rPr>
-              <a:t>LÉ</a:t>
-            </a:r>
-          </a:p>
-        </p:txBody>
-      </p:sp>
+        </p:spPr>
+      </p:pic>
       <p:sp>
         <p:nvSpPr>
           <p:cNvPr id="27" name="TextBox 26"/>
@@ -23692,8 +23659,8 @@
         </p:nvSpPr>
         <p:spPr>
           <a:xfrm>
-            <a:off x="7890641" y="2423160"/>
-            <a:ext cx="694944" cy="694944"/>
+            <a:off x="7844921" y="2377440"/>
+            <a:ext cx="786384" cy="786384"/>
           </a:xfrm>
           <a:prstGeom prst="ellipse">
             <a:avLst/>
@@ -23742,12 +23709,20 @@
           </a:p>
         </p:txBody>
       </p:sp>
-      <p:sp>
-        <p:nvSpPr>
-          <p:cNvPr id="33" name="TextBox 32"/>
-          <p:cNvSpPr txBox="1"/>
-          <p:nvPr/>
-        </p:nvSpPr>
+      <p:pic>
+        <p:nvPicPr>
+          <p:cNvPr id="33" name="Picture 32" descr="papy-le-jongleur.png"/>
+          <p:cNvPicPr>
+            <a:picLocks noChangeAspect="1"/>
+          </p:cNvPicPr>
+          <p:nvPr/>
+        </p:nvPicPr>
+        <p:blipFill>
+          <a:blip r:embed="rId5"/>
+          <a:stretch>
+            <a:fillRect/>
+          </a:stretch>
+        </p:blipFill>
         <p:spPr>
           <a:xfrm>
             <a:off x="7890641" y="2423160"/>
@@ -23756,27 +23731,8 @@
           <a:prstGeom prst="rect">
             <a:avLst/>
           </a:prstGeom>
-          <a:noFill/>
-        </p:spPr>
-        <p:txBody>
-          <a:bodyPr wrap="square" lIns="0" rIns="0" tIns="0" bIns="0" anchor="ctr">
-            <a:spAutoFit/>
-          </a:bodyPr>
-          <a:lstStyle/>
-          <a:p>
-            <a:pPr algn="ctr"/>
-            <a:r>
-              <a:rPr sz="2280" b="0">
-                <a:solidFill>
-                  <a:srgbClr val="FFFFFF"/>
-                </a:solidFill>
-                <a:latin typeface="Montserrat Black"/>
-              </a:rPr>
-              <a:t>PL</a:t>
-            </a:r>
-          </a:p>
-        </p:txBody>
-      </p:sp>
+        </p:spPr>
+      </p:pic>
       <p:sp>
         <p:nvSpPr>
           <p:cNvPr id="34" name="TextBox 33"/>
@@ -24003,8 +23959,8 @@
         </p:nvSpPr>
         <p:spPr>
           <a:xfrm>
-            <a:off x="10032769" y="2423160"/>
-            <a:ext cx="694944" cy="694944"/>
+            <a:off x="9987049" y="2377440"/>
+            <a:ext cx="786384" cy="786384"/>
           </a:xfrm>
           <a:prstGeom prst="ellipse">
             <a:avLst/>
@@ -24053,12 +24009,20 @@
           </a:p>
         </p:txBody>
       </p:sp>
-      <p:sp>
-        <p:nvSpPr>
-          <p:cNvPr id="40" name="TextBox 39"/>
-          <p:cNvSpPr txBox="1"/>
-          <p:nvPr/>
-        </p:nvSpPr>
+      <p:pic>
+        <p:nvPicPr>
+          <p:cNvPr id="40" name="Picture 39" descr="justine-kems.png"/>
+          <p:cNvPicPr>
+            <a:picLocks noChangeAspect="1"/>
+          </p:cNvPicPr>
+          <p:nvPr/>
+        </p:nvPicPr>
+        <p:blipFill>
+          <a:blip r:embed="rId6"/>
+          <a:stretch>
+            <a:fillRect/>
+          </a:stretch>
+        </p:blipFill>
         <p:spPr>
           <a:xfrm>
             <a:off x="10032769" y="2423160"/>
@@ -24067,27 +24031,8 @@
           <a:prstGeom prst="rect">
             <a:avLst/>
           </a:prstGeom>
-          <a:noFill/>
-        </p:spPr>
-        <p:txBody>
-          <a:bodyPr wrap="square" lIns="0" rIns="0" tIns="0" bIns="0" anchor="ctr">
-            <a:spAutoFit/>
-          </a:bodyPr>
-          <a:lstStyle/>
-          <a:p>
-            <a:pPr algn="ctr"/>
-            <a:r>
-              <a:rPr sz="2280" b="0">
-                <a:solidFill>
-                  <a:srgbClr val="FFFFFF"/>
-                </a:solidFill>
-                <a:latin typeface="Montserrat Black"/>
-              </a:rPr>
-              <a:t>JK</a:t>
-            </a:r>
-          </a:p>
-        </p:txBody>
-      </p:sp>
+        </p:spPr>
+      </p:pic>
       <p:sp>
         <p:nvSpPr>
           <p:cNvPr id="41" name="TextBox 40"/>
@@ -24314,8 +24259,8 @@
         </p:nvSpPr>
         <p:spPr>
           <a:xfrm>
-            <a:off x="1464256" y="4398264"/>
-            <a:ext cx="694944" cy="694944"/>
+            <a:off x="1418536" y="4352544"/>
+            <a:ext cx="786384" cy="786384"/>
           </a:xfrm>
           <a:prstGeom prst="ellipse">
             <a:avLst/>
@@ -24364,12 +24309,20 @@
           </a:p>
         </p:txBody>
       </p:sp>
-      <p:sp>
-        <p:nvSpPr>
-          <p:cNvPr id="47" name="TextBox 46"/>
-          <p:cNvSpPr txBox="1"/>
-          <p:nvPr/>
-        </p:nvSpPr>
+      <p:pic>
+        <p:nvPicPr>
+          <p:cNvPr id="47" name="Picture 46" descr="dilane-nofole-pro.png"/>
+          <p:cNvPicPr>
+            <a:picLocks noChangeAspect="1"/>
+          </p:cNvPicPr>
+          <p:nvPr/>
+        </p:nvPicPr>
+        <p:blipFill>
+          <a:blip r:embed="rId7"/>
+          <a:stretch>
+            <a:fillRect/>
+          </a:stretch>
+        </p:blipFill>
         <p:spPr>
           <a:xfrm>
             <a:off x="1464256" y="4398264"/>
@@ -24378,27 +24331,8 @@
           <a:prstGeom prst="rect">
             <a:avLst/>
           </a:prstGeom>
-          <a:noFill/>
-        </p:spPr>
-        <p:txBody>
-          <a:bodyPr wrap="square" lIns="0" rIns="0" tIns="0" bIns="0" anchor="ctr">
-            <a:spAutoFit/>
-          </a:bodyPr>
-          <a:lstStyle/>
-          <a:p>
-            <a:pPr algn="ctr"/>
-            <a:r>
-              <a:rPr sz="2280" b="0">
-                <a:solidFill>
-                  <a:srgbClr val="FFFFFF"/>
-                </a:solidFill>
-                <a:latin typeface="Montserrat Black"/>
-              </a:rPr>
-              <a:t>DN</a:t>
-            </a:r>
-          </a:p>
-        </p:txBody>
-      </p:sp>
+        </p:spPr>
+      </p:pic>
       <p:sp>
         <p:nvSpPr>
           <p:cNvPr id="48" name="TextBox 47"/>
@@ -24625,8 +24559,8 @@
         </p:nvSpPr>
         <p:spPr>
           <a:xfrm>
-            <a:off x="3606384" y="4398264"/>
-            <a:ext cx="694944" cy="694944"/>
+            <a:off x="3560664" y="4352544"/>
+            <a:ext cx="786384" cy="786384"/>
           </a:xfrm>
           <a:prstGeom prst="ellipse">
             <a:avLst/>
@@ -24675,12 +24609,20 @@
           </a:p>
         </p:txBody>
       </p:sp>
-      <p:sp>
-        <p:nvSpPr>
-          <p:cNvPr id="54" name="TextBox 53"/>
-          <p:cNvSpPr txBox="1"/>
-          <p:nvPr/>
-        </p:nvSpPr>
+      <p:pic>
+        <p:nvPicPr>
+          <p:cNvPr id="54" name="Picture 53" descr="kevin-chris-digital.png"/>
+          <p:cNvPicPr>
+            <a:picLocks noChangeAspect="1"/>
+          </p:cNvPicPr>
+          <p:nvPr/>
+        </p:nvPicPr>
+        <p:blipFill>
+          <a:blip r:embed="rId8"/>
+          <a:stretch>
+            <a:fillRect/>
+          </a:stretch>
+        </p:blipFill>
         <p:spPr>
           <a:xfrm>
             <a:off x="3606384" y="4398264"/>
@@ -24689,27 +24631,8 @@
           <a:prstGeom prst="rect">
             <a:avLst/>
           </a:prstGeom>
-          <a:noFill/>
-        </p:spPr>
-        <p:txBody>
-          <a:bodyPr wrap="square" lIns="0" rIns="0" tIns="0" bIns="0" anchor="ctr">
-            <a:spAutoFit/>
-          </a:bodyPr>
-          <a:lstStyle/>
-          <a:p>
-            <a:pPr algn="ctr"/>
-            <a:r>
-              <a:rPr sz="2280" b="0">
-                <a:solidFill>
-                  <a:srgbClr val="FFFFFF"/>
-                </a:solidFill>
-                <a:latin typeface="Montserrat Black"/>
-              </a:rPr>
-              <a:t>KC</a:t>
-            </a:r>
-          </a:p>
-        </p:txBody>
-      </p:sp>
+        </p:spPr>
+      </p:pic>
       <p:sp>
         <p:nvSpPr>
           <p:cNvPr id="55" name="TextBox 54"/>
@@ -24936,8 +24859,8 @@
         </p:nvSpPr>
         <p:spPr>
           <a:xfrm>
-            <a:off x="5748512" y="4398264"/>
-            <a:ext cx="694944" cy="694944"/>
+            <a:off x="5702792" y="4352544"/>
+            <a:ext cx="786384" cy="786384"/>
           </a:xfrm>
           <a:prstGeom prst="ellipse">
             <a:avLst/>
@@ -24986,12 +24909,20 @@
           </a:p>
         </p:txBody>
       </p:sp>
-      <p:sp>
-        <p:nvSpPr>
-          <p:cNvPr id="61" name="TextBox 60"/>
-          <p:cNvSpPr txBox="1"/>
-          <p:nvPr/>
-        </p:nvSpPr>
+      <p:pic>
+        <p:nvPicPr>
+          <p:cNvPr id="61" name="Picture 60" descr="mbanga-diaspora.png"/>
+          <p:cNvPicPr>
+            <a:picLocks noChangeAspect="1"/>
+          </p:cNvPicPr>
+          <p:nvPr/>
+        </p:nvPicPr>
+        <p:blipFill>
+          <a:blip r:embed="rId9"/>
+          <a:stretch>
+            <a:fillRect/>
+          </a:stretch>
+        </p:blipFill>
         <p:spPr>
           <a:xfrm>
             <a:off x="5748512" y="4398264"/>
@@ -25000,27 +24931,8 @@
           <a:prstGeom prst="rect">
             <a:avLst/>
           </a:prstGeom>
-          <a:noFill/>
-        </p:spPr>
-        <p:txBody>
-          <a:bodyPr wrap="square" lIns="0" rIns="0" tIns="0" bIns="0" anchor="ctr">
-            <a:spAutoFit/>
-          </a:bodyPr>
-          <a:lstStyle/>
-          <a:p>
-            <a:pPr algn="ctr"/>
-            <a:r>
-              <a:rPr sz="2280" b="0">
-                <a:solidFill>
-                  <a:srgbClr val="FFFFFF"/>
-                </a:solidFill>
-                <a:latin typeface="Montserrat Black"/>
-              </a:rPr>
-              <a:t>MD</a:t>
-            </a:r>
-          </a:p>
-        </p:txBody>
-      </p:sp>
+        </p:spPr>
+      </p:pic>
       <p:sp>
         <p:nvSpPr>
           <p:cNvPr id="62" name="TextBox 61"/>
@@ -25247,8 +25159,8 @@
         </p:nvSpPr>
         <p:spPr>
           <a:xfrm>
-            <a:off x="7890641" y="4398264"/>
-            <a:ext cx="694944" cy="694944"/>
+            <a:off x="7844921" y="4352544"/>
+            <a:ext cx="786384" cy="786384"/>
           </a:xfrm>
           <a:prstGeom prst="ellipse">
             <a:avLst/>
@@ -25297,12 +25209,20 @@
           </a:p>
         </p:txBody>
       </p:sp>
-      <p:sp>
-        <p:nvSpPr>
-          <p:cNvPr id="68" name="TextBox 67"/>
-          <p:cNvSpPr txBox="1"/>
-          <p:nvPr/>
-        </p:nvSpPr>
+      <p:pic>
+        <p:nvPicPr>
+          <p:cNvPr id="68" name="Picture 67" descr="alain-tchamo-officiel.png"/>
+          <p:cNvPicPr>
+            <a:picLocks noChangeAspect="1"/>
+          </p:cNvPicPr>
+          <p:nvPr/>
+        </p:nvPicPr>
+        <p:blipFill>
+          <a:blip r:embed="rId10"/>
+          <a:stretch>
+            <a:fillRect/>
+          </a:stretch>
+        </p:blipFill>
         <p:spPr>
           <a:xfrm>
             <a:off x="7890641" y="4398264"/>
@@ -25311,27 +25231,8 @@
           <a:prstGeom prst="rect">
             <a:avLst/>
           </a:prstGeom>
-          <a:noFill/>
-        </p:spPr>
-        <p:txBody>
-          <a:bodyPr wrap="square" lIns="0" rIns="0" tIns="0" bIns="0" anchor="ctr">
-            <a:spAutoFit/>
-          </a:bodyPr>
-          <a:lstStyle/>
-          <a:p>
-            <a:pPr algn="ctr"/>
-            <a:r>
-              <a:rPr sz="2280" b="0">
-                <a:solidFill>
-                  <a:srgbClr val="FFFFFF"/>
-                </a:solidFill>
-                <a:latin typeface="Montserrat Black"/>
-              </a:rPr>
-              <a:t>AT</a:t>
-            </a:r>
-          </a:p>
-        </p:txBody>
-      </p:sp>
+        </p:spPr>
+      </p:pic>
       <p:sp>
         <p:nvSpPr>
           <p:cNvPr id="69" name="TextBox 68"/>
@@ -25558,8 +25459,8 @@
         </p:nvSpPr>
         <p:spPr>
           <a:xfrm>
-            <a:off x="10032769" y="4398264"/>
-            <a:ext cx="694944" cy="694944"/>
+            <a:off x="9987049" y="4352544"/>
+            <a:ext cx="786384" cy="786384"/>
           </a:xfrm>
           <a:prstGeom prst="ellipse">
             <a:avLst/>
@@ -25608,12 +25509,20 @@
           </a:p>
         </p:txBody>
       </p:sp>
-      <p:sp>
-        <p:nvSpPr>
-          <p:cNvPr id="75" name="TextBox 74"/>
-          <p:cNvSpPr txBox="1"/>
-          <p:nvPr/>
-        </p:nvSpPr>
+      <p:pic>
+        <p:nvPicPr>
+          <p:cNvPr id="75" name="Picture 74" descr="dj-styvo-godson.png"/>
+          <p:cNvPicPr>
+            <a:picLocks noChangeAspect="1"/>
+          </p:cNvPicPr>
+          <p:nvPr/>
+        </p:nvPicPr>
+        <p:blipFill>
+          <a:blip r:embed="rId11"/>
+          <a:stretch>
+            <a:fillRect/>
+          </a:stretch>
+        </p:blipFill>
         <p:spPr>
           <a:xfrm>
             <a:off x="10032769" y="4398264"/>
@@ -25622,27 +25531,8 @@
           <a:prstGeom prst="rect">
             <a:avLst/>
           </a:prstGeom>
-          <a:noFill/>
-        </p:spPr>
-        <p:txBody>
-          <a:bodyPr wrap="square" lIns="0" rIns="0" tIns="0" bIns="0" anchor="ctr">
-            <a:spAutoFit/>
-          </a:bodyPr>
-          <a:lstStyle/>
-          <a:p>
-            <a:pPr algn="ctr"/>
-            <a:r>
-              <a:rPr sz="2280" b="0">
-                <a:solidFill>
-                  <a:srgbClr val="FFFFFF"/>
-                </a:solidFill>
-                <a:latin typeface="Montserrat Black"/>
-              </a:rPr>
-              <a:t>DS</a:t>
-            </a:r>
-          </a:p>
-        </p:txBody>
-      </p:sp>
+        </p:spPr>
+      </p:pic>
       <p:sp>
         <p:nvSpPr>
           <p:cNvPr id="76" name="TextBox 75"/>

</xml_diff>

<commit_message>
Ajoute la photo de Kevin sur la couverture et le slide "Et maintenant ?"
- Couverture : avatar rond (photo) dans le bloc présentateur.
- "Et maintenant ?" : grand portrait à droite + cartouche nom,
  texte resserré à gauche.

Co-Authored-By: Claude Opus 4.8 <noreply@anthropic.com>
Claude-Session: https://claude.ai/code/session_01SEzgxP8UjCbxgDgZR7qL7k
</commit_message>
<xml_diff>
--- a/Masterclass_Facebook_KevinChris_REDESIGN.pptx
+++ b/Masterclass_Facebook_KevinChris_REDESIGN.pptx
@@ -5304,19 +5304,17 @@
       </p:sp>
       <p:sp>
         <p:nvSpPr>
-          <p:cNvPr id="12" name="Rounded Rectangle 11"/>
+          <p:cNvPr id="12" name="Oval 11"/>
           <p:cNvSpPr/>
           <p:nvPr/>
         </p:nvSpPr>
         <p:spPr>
           <a:xfrm>
-            <a:off x="1078992" y="5248656"/>
-            <a:ext cx="640080" cy="640080"/>
-          </a:xfrm>
-          <a:prstGeom prst="roundRect">
-            <a:avLst>
-              <a:gd name="adj" fmla="val 30000"/>
-            </a:avLst>
+            <a:off x="1033272" y="5202936"/>
+            <a:ext cx="731519" cy="731519"/>
+          </a:xfrm>
+          <a:prstGeom prst="ellipse">
+            <a:avLst/>
           </a:prstGeom>
           <a:gradFill rotWithShape="1">
             <a:gsLst>
@@ -5333,9 +5331,9 @@
             <a:noFill/>
           </a:ln>
           <a:effectLst>
-            <a:outerShdw blurRad="203200" dist="76200" dir="5400000" rotWithShape="0">
-              <a:srgbClr val="9B6DFF">
-                <a:alpha val="45000"/>
+            <a:outerShdw blurRad="228600" dist="127000" dir="5400000" rotWithShape="0">
+              <a:srgbClr val="000000">
+                <a:alpha val="58000"/>
               </a:srgbClr>
             </a:outerShdw>
           </a:effectLst>
@@ -5364,7 +5362,7 @@
       </p:sp>
       <p:pic>
         <p:nvPicPr>
-          <p:cNvPr id="13" name="Picture 12" descr="image-1-1.png"/>
+          <p:cNvPr id="13" name="Picture 12" descr="kevin-chris-digital.png"/>
           <p:cNvPicPr>
             <a:picLocks noChangeAspect="1"/>
           </p:cNvPicPr>
@@ -5378,8 +5376,8 @@
         </p:blipFill>
         <p:spPr>
           <a:xfrm>
-            <a:off x="1225296" y="5394960"/>
-            <a:ext cx="347471" cy="347471"/>
+            <a:off x="1078992" y="5248656"/>
+            <a:ext cx="640080" cy="640080"/>
           </a:xfrm>
           <a:prstGeom prst="rect">
             <a:avLst/>
@@ -16507,7 +16505,7 @@
         </p:nvSpPr>
         <p:spPr>
           <a:xfrm>
-            <a:off x="841248" y="4526280"/>
+            <a:off x="841248" y="3767328"/>
             <a:ext cx="457200" cy="457200"/>
           </a:xfrm>
           <a:prstGeom prst="roundRect">
@@ -16575,7 +16573,7 @@
         </p:blipFill>
         <p:spPr>
           <a:xfrm>
-            <a:off x="941832" y="4626864"/>
+            <a:off x="941832" y="3867912"/>
             <a:ext cx="256032" cy="256032"/>
           </a:xfrm>
           <a:prstGeom prst="rect">
@@ -16591,8 +16589,8 @@
         </p:nvSpPr>
         <p:spPr>
           <a:xfrm>
-            <a:off x="1517904" y="4526280"/>
-            <a:ext cx="8961120" cy="457200"/>
+            <a:off x="1517904" y="3767328"/>
+            <a:ext cx="6400800" cy="457200"/>
           </a:xfrm>
           <a:prstGeom prst="rect">
             <a:avLst/>
@@ -16605,9 +16603,13 @@
           </a:bodyPr>
           <a:lstStyle/>
           <a:p>
-            <a:pPr algn="l"/>
-            <a:r>
-              <a:rPr sz="1500" b="0">
+            <a:pPr algn="l">
+              <a:lnSpc>
+                <a:spcPct val="108000"/>
+              </a:lnSpc>
+            </a:pPr>
+            <a:r>
+              <a:rPr sz="1400" b="0">
                 <a:solidFill>
                   <a:srgbClr val="F4F7FF"/>
                 </a:solidFill>
@@ -16626,7 +16628,7 @@
         </p:nvSpPr>
         <p:spPr>
           <a:xfrm>
-            <a:off x="841248" y="5129784"/>
+            <a:off x="841248" y="4425696"/>
             <a:ext cx="457200" cy="457200"/>
           </a:xfrm>
           <a:prstGeom prst="roundRect">
@@ -16694,7 +16696,7 @@
         </p:blipFill>
         <p:spPr>
           <a:xfrm>
-            <a:off x="941832" y="5230368"/>
+            <a:off x="941832" y="4526280"/>
             <a:ext cx="256032" cy="256032"/>
           </a:xfrm>
           <a:prstGeom prst="rect">
@@ -16710,8 +16712,8 @@
         </p:nvSpPr>
         <p:spPr>
           <a:xfrm>
-            <a:off x="1517904" y="5129784"/>
-            <a:ext cx="8961120" cy="457200"/>
+            <a:off x="1517904" y="4425696"/>
+            <a:ext cx="6400800" cy="457200"/>
           </a:xfrm>
           <a:prstGeom prst="rect">
             <a:avLst/>
@@ -16724,9 +16726,13 @@
           </a:bodyPr>
           <a:lstStyle/>
           <a:p>
-            <a:pPr algn="l"/>
-            <a:r>
-              <a:rPr sz="1500" b="0">
+            <a:pPr algn="l">
+              <a:lnSpc>
+                <a:spcPct val="108000"/>
+              </a:lnSpc>
+            </a:pPr>
+            <a:r>
+              <a:rPr sz="1400" b="0">
                 <a:solidFill>
                   <a:srgbClr val="F4F7FF"/>
                 </a:solidFill>
@@ -16745,7 +16751,7 @@
         </p:nvSpPr>
         <p:spPr>
           <a:xfrm>
-            <a:off x="841248" y="5733288"/>
+            <a:off x="841248" y="5084064"/>
             <a:ext cx="457200" cy="457200"/>
           </a:xfrm>
           <a:prstGeom prst="roundRect">
@@ -16813,7 +16819,7 @@
         </p:blipFill>
         <p:spPr>
           <a:xfrm>
-            <a:off x="941832" y="5833872"/>
+            <a:off x="941832" y="5184648"/>
             <a:ext cx="256032" cy="256032"/>
           </a:xfrm>
           <a:prstGeom prst="rect">
@@ -16829,8 +16835,8 @@
         </p:nvSpPr>
         <p:spPr>
           <a:xfrm>
-            <a:off x="1517904" y="5733288"/>
-            <a:ext cx="8961120" cy="457200"/>
+            <a:off x="1517904" y="5084064"/>
+            <a:ext cx="6400800" cy="457200"/>
           </a:xfrm>
           <a:prstGeom prst="rect">
             <a:avLst/>
@@ -16843,9 +16849,13 @@
           </a:bodyPr>
           <a:lstStyle/>
           <a:p>
-            <a:pPr algn="l"/>
-            <a:r>
-              <a:rPr sz="1500" b="0">
+            <a:pPr algn="l">
+              <a:lnSpc>
+                <a:spcPct val="108000"/>
+              </a:lnSpc>
+            </a:pPr>
+            <a:r>
+              <a:rPr sz="1400" b="0">
                 <a:solidFill>
                   <a:srgbClr val="F4F7FF"/>
                 </a:solidFill>
@@ -16858,7 +16868,179 @@
       </p:sp>
       <p:sp>
         <p:nvSpPr>
-          <p:cNvPr id="18" name="TextBox 17"/>
+          <p:cNvPr id="18" name="Oval 17"/>
+          <p:cNvSpPr/>
+          <p:nvPr/>
+        </p:nvSpPr>
+        <p:spPr>
+          <a:xfrm>
+            <a:off x="8595359" y="3264408"/>
+            <a:ext cx="2560320" cy="2560320"/>
+          </a:xfrm>
+          <a:prstGeom prst="ellipse">
+            <a:avLst/>
+          </a:prstGeom>
+          <a:gradFill rotWithShape="1">
+            <a:gsLst>
+              <a:gs pos="0">
+                <a:srgbClr val="5B8DEF"/>
+              </a:gs>
+              <a:gs pos="100000">
+                <a:srgbClr val="9B6DFF"/>
+              </a:gs>
+            </a:gsLst>
+            <a:lin ang="7500000" scaled="1"/>
+          </a:gradFill>
+          <a:ln>
+            <a:noFill/>
+          </a:ln>
+          <a:effectLst>
+            <a:outerShdw blurRad="228600" dist="127000" dir="5400000" rotWithShape="0">
+              <a:srgbClr val="000000">
+                <a:alpha val="58000"/>
+              </a:srgbClr>
+            </a:outerShdw>
+          </a:effectLst>
+        </p:spPr>
+        <p:style>
+          <a:lnRef idx="1">
+            <a:schemeClr val="accent1"/>
+          </a:lnRef>
+          <a:fillRef idx="3">
+            <a:schemeClr val="accent1"/>
+          </a:fillRef>
+          <a:effectRef idx="2">
+            <a:schemeClr val="accent1"/>
+          </a:effectRef>
+          <a:fontRef idx="minor">
+            <a:schemeClr val="lt1"/>
+          </a:fontRef>
+        </p:style>
+        <p:txBody>
+          <a:bodyPr rtlCol="0" anchor="ctr"/>
+          <a:lstStyle/>
+          <a:p>
+            <a:pPr algn="ctr"/>
+          </a:p>
+        </p:txBody>
+      </p:sp>
+      <p:pic>
+        <p:nvPicPr>
+          <p:cNvPr id="19" name="Picture 18" descr="kevin-chris-digital.png"/>
+          <p:cNvPicPr>
+            <a:picLocks noChangeAspect="1"/>
+          </p:cNvPicPr>
+          <p:nvPr/>
+        </p:nvPicPr>
+        <p:blipFill>
+          <a:blip r:embed="rId5"/>
+          <a:stretch>
+            <a:fillRect/>
+          </a:stretch>
+        </p:blipFill>
+        <p:spPr>
+          <a:xfrm>
+            <a:off x="8641080" y="3310128"/>
+            <a:ext cx="2468880" cy="2468880"/>
+          </a:xfrm>
+          <a:prstGeom prst="rect">
+            <a:avLst/>
+          </a:prstGeom>
+        </p:spPr>
+      </p:pic>
+      <p:sp>
+        <p:nvSpPr>
+          <p:cNvPr id="20" name="Rounded Rectangle 19"/>
+          <p:cNvSpPr/>
+          <p:nvPr/>
+        </p:nvSpPr>
+        <p:spPr>
+          <a:xfrm>
+            <a:off x="8641080" y="5925312"/>
+            <a:ext cx="2468880" cy="310896"/>
+          </a:xfrm>
+          <a:prstGeom prst="roundRect">
+            <a:avLst>
+              <a:gd name="adj" fmla="val 50000"/>
+            </a:avLst>
+          </a:prstGeom>
+          <a:solidFill>
+            <a:srgbClr val="1E2A4A"/>
+          </a:solidFill>
+          <a:ln w="12700">
+            <a:solidFill>
+              <a:srgbClr val="3A4A78"/>
+            </a:solidFill>
+          </a:ln>
+        </p:spPr>
+        <p:style>
+          <a:lnRef idx="1">
+            <a:schemeClr val="accent1"/>
+          </a:lnRef>
+          <a:fillRef idx="3">
+            <a:schemeClr val="accent1"/>
+          </a:fillRef>
+          <a:effectRef idx="2">
+            <a:schemeClr val="accent1"/>
+          </a:effectRef>
+          <a:fontRef idx="minor">
+            <a:schemeClr val="lt1"/>
+          </a:fontRef>
+        </p:style>
+        <p:txBody>
+          <a:bodyPr rtlCol="0" anchor="ctr"/>
+          <a:lstStyle/>
+          <a:p>
+            <a:pPr algn="ctr"/>
+          </a:p>
+        </p:txBody>
+      </p:sp>
+      <p:sp>
+        <p:nvSpPr>
+          <p:cNvPr id="21" name="TextBox 20"/>
+          <p:cNvSpPr txBox="1"/>
+          <p:nvPr/>
+        </p:nvSpPr>
+        <p:spPr>
+          <a:xfrm>
+            <a:off x="8641080" y="5925312"/>
+            <a:ext cx="2468880" cy="310896"/>
+          </a:xfrm>
+          <a:prstGeom prst="rect">
+            <a:avLst/>
+          </a:prstGeom>
+          <a:noFill/>
+        </p:spPr>
+        <p:txBody>
+          <a:bodyPr wrap="square" lIns="0" rIns="0" tIns="0" bIns="0" anchor="ctr">
+            <a:spAutoFit/>
+          </a:bodyPr>
+          <a:lstStyle/>
+          <a:p>
+            <a:pPr algn="ctr"/>
+            <a:r>
+              <a:rPr sz="1050" b="0">
+                <a:gradFill rotWithShape="1">
+                  <a:gsLst>
+                    <a:gs pos="0">
+                      <a:srgbClr val="5B8DEF"/>
+                    </a:gs>
+                    <a:gs pos="100000">
+                      <a:srgbClr val="9B6DFF"/>
+                    </a:gs>
+                  </a:gsLst>
+                  <a:lin ang="0" scaled="1"/>
+                </a:gradFill>
+                <a:latin typeface="Inter SemiBold"/>
+              </a:rPr>
+              <a:t>Kevin Chris Atchof</a:t>
+            </a:r>
+          </a:p>
+        </p:txBody>
+      </p:sp>
+      <p:sp>
+        <p:nvSpPr>
+          <p:cNvPr id="22" name="TextBox 21"/>
           <p:cNvSpPr txBox="1"/>
           <p:nvPr/>
         </p:nvSpPr>
@@ -20414,7 +20596,7 @@
       </p:sp>
       <p:pic>
         <p:nvPicPr>
-          <p:cNvPr id="35" name="Picture 34" descr="image-1-1.png"/>
+          <p:cNvPr id="35" name="Picture 34" descr="image-18-3.png"/>
           <p:cNvPicPr>
             <a:picLocks noChangeAspect="1"/>
           </p:cNvPicPr>
@@ -35057,7 +35239,7 @@
       </p:sp>
       <p:pic>
         <p:nvPicPr>
-          <p:cNvPr id="11" name="Picture 10" descr="image-1-1.png"/>
+          <p:cNvPr id="11" name="Picture 10" descr="image-18-3.png"/>
           <p:cNvPicPr>
             <a:picLocks noChangeAspect="1"/>
           </p:cNvPicPr>

</xml_diff>